<commit_message>
Compact deck: realized sparsity (AIME ~4%, 32K ~79%, 64K ~88%), AIME page wording, corrected M1/M2 definitions
Co-Authored-By: Claude Opus 5.5 <noreply@anthropic.com>
</commit_message>
<xml_diff>
--- a/results/m1_m2_m3_frontier_v27_20260929/ppt_sample/dlm_sparse_attention_20261001_compact_v2.pptx
+++ b/results/m1_m2_m3_frontier_v27_20260929/ppt_sample/dlm_sparse_attention_20261001_compact_v2.pptx
@@ -924,6 +924,11 @@
           <a:p>
             <a:r>
               <a:t>【协议】E7 v27_aime_confirm_e7_0515fa3125588ff0，1,260/1,260 成功，每格同机。最好变体 = M3 优化版 + carry0 + 2K 门控（key &lt; 2K 的调用走原生 dense，约 31% 的 GLOBAL 调用）；纯生成 1.005、每步 1.005。M3 优化版 1.033（答对 96）；原版 M1/M2/M3 端到端 1.089/1.115/1.069。</a:t>
+            </a:r>
+          </a:p>
+          <a:p>
+            <a:r>
+              <a:t>【实际稀疏度】fidelity_v6/README.md（诊断，每类 2 个请求，底座 v2）：稀疏调用中保留块比例中位数，M3 R6 DP −ln2：32K 0.21、64K 0.12、AIME 0.96；原版 M1 0.22/0.15/0.95，原版 M3 0.21/0.15/0.93，B 0.15/0.10/0.90。不含每个 canvas 的 dense 步与 canvas 块。</a:t>
             </a:r>
           </a:p>
           <a:p>
@@ -5052,7 +5057,7 @@
                         <a:rPr sz="1100" b="0">
                           <a:latin typeface="Microsoft YaHei"/>
                         </a:rPr>
-                        <a:t>每个块的“跳过风险” = 注意力质量（来自历史 QK 观测）×（块内 V 的 32 维随机投影 − 当前输出）的范数 × query 敏感度；风险低于阈值就跳过；每步重新决策</a:t>
+                        <a:t>每个块的“跳过风险” = 注意力质量（来自历史 QK 观测）×（块内按注意力加权的 V 均值 − 当前输出）的范数 × query 敏感度，V 先随机投影到 32 维；风险低于阈值就跳过；每步重新决策</a:t>
                       </a:r>
                     </a:p>
                   </a:txBody>
@@ -5099,7 +5104,7 @@
                         <a:rPr sz="1100" b="0">
                           <a:latin typeface="Microsoft YaHei"/>
                         </a:rPr>
-                        <a:t>同 M1，但 V 用块内均值（不投影、不按注意力加权）</a:t>
+                        <a:t>同 M1，但块内 V 取简单平均（不按注意力加权；同样在 32 维投影空间）</a:t>
                       </a:r>
                     </a:p>
                   </a:txBody>
@@ -8873,7 +8878,7 @@
         </p:nvGraphicFramePr>
         <p:xfrm>
           <a:off x="320040" y="1280160"/>
-          <a:ext cx="11521437" cy="2468880"/>
+          <a:ext cx="11521437" cy="2743200"/>
         </p:xfrm>
         <a:graphic>
           <a:graphicData uri="http://schemas.openxmlformats.org/drawingml/2006/table">
@@ -9324,6 +9329,68 @@
                         <a:rPr sz="1100" b="0">
                           <a:latin typeface="Microsoft YaHei"/>
                         </a:rPr>
+                        <a:t>主线（M3 优化版 −ln2）稀疏调用中实际跳过的块</a:t>
+                      </a:r>
+                    </a:p>
+                  </a:txBody>
+                  <a:tcPr/>
+                </a:tc>
+                <a:tc>
+                  <a:txBody>
+                    <a:bodyPr/>
+                    <a:lstStyle/>
+                    <a:p>
+                      <a:r>
+                        <a:rPr sz="1100" b="0">
+                          <a:latin typeface="Microsoft YaHei"/>
+                        </a:rPr>
+                        <a:t>约 4%（保留 96%）</a:t>
+                      </a:r>
+                    </a:p>
+                  </a:txBody>
+                  <a:tcPr/>
+                </a:tc>
+                <a:tc>
+                  <a:txBody>
+                    <a:bodyPr/>
+                    <a:lstStyle/>
+                    <a:p>
+                      <a:r>
+                        <a:rPr sz="1100" b="0">
+                          <a:latin typeface="Microsoft YaHei"/>
+                        </a:rPr>
+                        <a:t>约 79%</a:t>
+                      </a:r>
+                    </a:p>
+                  </a:txBody>
+                  <a:tcPr/>
+                </a:tc>
+                <a:tc>
+                  <a:txBody>
+                    <a:bodyPr/>
+                    <a:lstStyle/>
+                    <a:p>
+                      <a:r>
+                        <a:rPr sz="1100" b="0">
+                          <a:latin typeface="Microsoft YaHei"/>
+                        </a:rPr>
+                        <a:t>约 88%</a:t>
+                      </a:r>
+                    </a:p>
+                  </a:txBody>
+                  <a:tcPr/>
+                </a:tc>
+              </a:tr>
+              <a:tr h="274320">
+                <a:tc>
+                  <a:txBody>
+                    <a:bodyPr/>
+                    <a:lstStyle/>
+                    <a:p>
+                      <a:r>
+                        <a:rPr sz="1100" b="0">
+                          <a:latin typeface="Microsoft YaHei"/>
+                        </a:rPr>
                         <a:t>M3 优化版每步耗时</a:t>
                       </a:r>
                     </a:p>
@@ -9450,7 +9517,7 @@
         </p:nvSpPr>
         <p:spPr>
           <a:xfrm>
-            <a:off x="320040" y="4023359"/>
+            <a:off x="320040" y="4297679"/>
             <a:ext cx="11521440" cy="1097280"/>
           </a:xfrm>
           <a:prstGeom prst="rect">
@@ -9486,7 +9553,7 @@
               <a:rPr sz="1200" b="0">
                 <a:latin typeface="Microsoft YaHei"/>
               </a:rPr>
-              <a:t>• key 少（中位数约 57 个块，其中 4 个 canvas 块必须保留）：70% 的 prefix 稀疏度只对应约 60% 的总块稀疏度；28% 的调用不到 2K key（门控后直接走 dense）。</a:t>
+              <a:t>• 主线阈值在 AIME 上只跳约 4% 的块：key 少（中位数约 57 个块，4 个 canvas 块必须保留），每个块的风险都不低；28% 的调用不到 2K key。强行跳 70%（第 6 页 E8）就掉点、变慢。</a:t>
             </a:r>
           </a:p>
           <a:p>
@@ -9592,7 +9659,7 @@
                 </a:solidFill>
                 <a:latin typeface="Microsoft YaHei"/>
               </a:rPr>
-              <a:t>AIME：M3 优化版固定保留 30% prefix 块（E8，180 格/组）· 64K：M3 优化版 + carry0 固定保留 12%（E9，24 题 × 4 seed = 96 格/组）· 只换风险里的 V 项</a:t>
+              <a:t>AIME：固定保留 30% prefix 块（E8，180 格/组；主线阈值在 AIME 只跳约 4%）· 64K：M3 优化版 + carry0 固定保留 12%（E9，96 格/组；= 主线 64K 工作点）· 只换风险里的 V 项</a:t>
             </a:r>
           </a:p>
         </p:txBody>

</xml_diff>